<commit_message>
Simplify business card type system to two families (VAR-B)
Drops Instrument Serif and JetBrains Mono from card.html and EB Garamond /
JetBrains Mono / Hiragino Mincho from build_meishi.py. The card now reads
in Hubot Sans + IBM Plex Sans JP (web preview) and Helvetica Neue +
Hiragino Sans (print PPTX). Front and back share a single bottom-strip
rule so the structural hairlines align between faces; email and URL use
the same weight/tracking. The back paraphrase is set as a code-comment
gesture (// untangle what is tangled) with mixed letter/word spacing for
breathing room. Strips out unused PPTX-only ornaments (Independent title,
discipline lattices, top-right wordmark) so both faces match the simplified
HTML composition.

card-simple.html and card-varB.html retained as design exploration history.

Co-Authored-By: Claude Opus 4.7 (1M context) <noreply@anthropic.com>
</commit_message>
<xml_diff>
--- a/business_cards/abe_shinji_yoko.pptx
+++ b/business_cards/abe_shinji_yoko.pptx
@@ -830,14 +830,62 @@
       </p:sp>
       <p:sp>
         <p:nvSpPr>
+          <p:cNvPr id="110" name="top-label"/>
+          <p:cNvSpPr txBox="1"/>
+          <p:nvPr/>
+        </p:nvSpPr>
+        <p:spPr>
+          <a:xfrm>
+            <a:off x="216000" y="244800"/>
+            <a:ext cx="1080000" cy="126000"/>
+          </a:xfrm>
+          <a:prstGeom prst="rect">
+            <a:avLst/>
+          </a:prstGeom>
+          <a:noFill/>
+        </p:spPr>
+        <p:txBody>
+          <a:bodyPr wrap="square" lIns="0" tIns="0" rIns="0" bIns="0" rtlCol="0" anchor="t">
+            <a:noAutofit/>
+          </a:bodyPr>
+          <a:lstStyle/>
+          <a:p>
+            <a:pPr algn="l"/>
+            <a:r>
+              <a:rPr lang="ja-JP" sz="600" b="1" kern="0">
+                <a:solidFill>
+                  <a:srgbClr val="FF3B1C"/>
+                </a:solidFill>
+                <a:latin typeface="Helvetica Neue"/>
+                <a:ea typeface="Hiragino Sans"/>
+                <a:cs typeface="Helvetica Neue"/>
+              </a:rPr>
+              <a:t>§</a:t>
+            </a:r>
+            <a:r>
+              <a:rPr lang="ja-JP" sz="600" b="1" spc="168" kern="0">
+                <a:solidFill>
+                  <a:srgbClr val="A3A098"/>
+                </a:solidFill>
+                <a:latin typeface="Helvetica Neue"/>
+                <a:ea typeface="Hiragino Sans"/>
+                <a:cs typeface="Helvetica Neue"/>
+              </a:rPr>
+              <a:t>  IDENTITY</a:t>
+            </a:r>
+          </a:p>
+        </p:txBody>
+      </p:sp>
+      <p:sp>
+        <p:nvSpPr>
           <p:cNvPr id="101" name="rule-top"/>
           <p:cNvSpPr/>
           <p:nvPr/>
         </p:nvSpPr>
         <p:spPr>
           <a:xfrm>
-            <a:off x="288000" y="410400"/>
-            <a:ext cx="2916000" cy="3600"/>
+            <a:off x="216000" y="410400"/>
+            <a:ext cx="3060000" cy="3600"/>
           </a:xfrm>
           <a:prstGeom prst="rect">
             <a:avLst/>
@@ -859,14 +907,43 @@
       </p:sp>
       <p:sp>
         <p:nvSpPr>
-          <p:cNvPr id="110" name="section-index"/>
+          <p:cNvPr id="190" name="rule-bottom"/>
+          <p:cNvSpPr/>
+          <p:nvPr/>
+        </p:nvSpPr>
+        <p:spPr>
+          <a:xfrm>
+            <a:off x="216000" y="1857600"/>
+            <a:ext cx="3060000" cy="3600"/>
+          </a:xfrm>
+          <a:prstGeom prst="rect">
+            <a:avLst/>
+          </a:prstGeom>
+          <a:solidFill>
+            <a:srgbClr val="5A5852"/>
+          </a:solidFill>
+          <a:ln>
+            <a:noFill/>
+          </a:ln>
+        </p:spPr>
+        <p:txBody>
+          <a:bodyPr/>
+          <a:lstStyle/>
+          <a:p>
+            <a:endParaRPr lang="ja-JP"/>
+          </a:p>
+        </p:txBody>
+      </p:sp>
+      <p:sp>
+        <p:nvSpPr>
+          <p:cNvPr id="192" name="bottom-accent"/>
           <p:cNvSpPr txBox="1"/>
           <p:nvPr/>
         </p:nvSpPr>
         <p:spPr>
           <a:xfrm>
-            <a:off x="288000" y="244800"/>
-            <a:ext cx="1080000" cy="126000"/>
+            <a:off x="3096000" y="1911600"/>
+            <a:ext cx="180000" cy="144000"/>
           </a:xfrm>
           <a:prstGeom prst="rect">
             <a:avLst/>
@@ -879,42 +956,31 @@
           </a:bodyPr>
           <a:lstStyle/>
           <a:p>
-            <a:pPr algn="l"/>
-            <a:r>
-              <a:rPr lang="ja-JP" sz="650" b="1" spc="117" kern="0">
+            <a:pPr algn="r"/>
+            <a:r>
+              <a:rPr lang="ja-JP" sz="900" b="1" kern="0">
                 <a:solidFill>
                   <a:srgbClr val="FF3B1C"/>
                 </a:solidFill>
-                <a:latin typeface="JetBrains Mono"/>
-                <a:ea typeface="Hiragino Sans"/>
-                <a:cs typeface="JetBrains Mono"/>
+                <a:latin typeface="Helvetica Neue"/>
+                <a:ea typeface="Hiragino Sans"/>
+                <a:cs typeface="Helvetica Neue"/>
               </a:rPr>
               <a:t>§</a:t>
             </a:r>
-            <a:r>
-              <a:rPr lang="ja-JP" sz="650" spc="117" kern="0">
-                <a:solidFill>
-                  <a:srgbClr val="5A5852"/>
-                </a:solidFill>
-                <a:latin typeface="JetBrains Mono"/>
-                <a:ea typeface="Hiragino Sans"/>
-                <a:cs typeface="JetBrains Mono"/>
-              </a:rPr>
-              <a:t> 001</a:t>
-            </a:r>
-          </a:p>
-        </p:txBody>
-      </p:sp>
-      <p:sp>
-        <p:nvSpPr>
-          <p:cNvPr id="111" name="wordmark"/>
+          </a:p>
+        </p:txBody>
+      </p:sp>
+      <p:sp>
+        <p:nvSpPr>
+          <p:cNvPr id="120" name="name-en"/>
           <p:cNvSpPr txBox="1"/>
           <p:nvPr/>
         </p:nvSpPr>
         <p:spPr>
           <a:xfrm>
-            <a:off x="1980000" y="244800"/>
-            <a:ext cx="1224000" cy="126000"/>
+            <a:off x="216000" y="630000"/>
+            <a:ext cx="3060000" cy="432000"/>
           </a:xfrm>
           <a:prstGeom prst="rect">
             <a:avLst/>
@@ -927,31 +993,31 @@
           </a:bodyPr>
           <a:lstStyle/>
           <a:p>
-            <a:pPr algn="r"/>
-            <a:r>
-              <a:rPr lang="ja-JP" sz="650" b="1" spc="143" kern="0">
+            <a:pPr algn="l"/>
+            <a:r>
+              <a:rPr lang="ja-JP" sz="2600" b="1" spc="-65" kern="0">
                 <a:solidFill>
                   <a:srgbClr val="0E0E0C"/>
                 </a:solidFill>
-                <a:latin typeface="JetBrains Mono"/>
-                <a:ea typeface="Hiragino Sans"/>
-                <a:cs typeface="JetBrains Mono"/>
-              </a:rPr>
-              <a:t>TANGLETECK</a:t>
-            </a:r>
-          </a:p>
-        </p:txBody>
-      </p:sp>
-      <p:sp>
-        <p:nvSpPr>
-          <p:cNvPr id="120" name="name-en"/>
+                <a:latin typeface="Helvetica Neue"/>
+                <a:ea typeface="Hiragino Sans"/>
+                <a:cs typeface="Helvetica Neue"/>
+              </a:rPr>
+              <a:t>ABE SHINJI</a:t>
+            </a:r>
+          </a:p>
+        </p:txBody>
+      </p:sp>
+      <p:sp>
+        <p:nvSpPr>
+          <p:cNvPr id="121" name="name-jp"/>
           <p:cNvSpPr txBox="1"/>
           <p:nvPr/>
         </p:nvSpPr>
         <p:spPr>
           <a:xfrm>
-            <a:off x="288000" y="630000"/>
-            <a:ext cx="2808000" cy="432000"/>
+            <a:off x="216000" y="1137600"/>
+            <a:ext cx="3060000" cy="180000"/>
           </a:xfrm>
           <a:prstGeom prst="rect">
             <a:avLst/>
@@ -966,29 +1032,29 @@
           <a:p>
             <a:pPr algn="l"/>
             <a:r>
-              <a:rPr lang="ja-JP" sz="2600" b="1" spc="-78" kern="0">
-                <a:solidFill>
-                  <a:srgbClr val="0E0E0C"/>
-                </a:solidFill>
-                <a:latin typeface="Helvetica Neue"/>
-                <a:ea typeface="Hiragino Sans"/>
-                <a:cs typeface="Helvetica Neue"/>
-              </a:rPr>
-              <a:t>ABE SHINJI</a:t>
-            </a:r>
-          </a:p>
-        </p:txBody>
-      </p:sp>
-      <p:sp>
-        <p:nvSpPr>
-          <p:cNvPr id="121" name="name-jp"/>
+              <a:rPr lang="ja-JP" sz="1100" spc="198" kern="0">
+                <a:solidFill>
+                  <a:srgbClr val="5A5852"/>
+                </a:solidFill>
+                <a:latin typeface="Helvetica Neue"/>
+                <a:ea typeface="Hiragino Sans"/>
+                <a:cs typeface="Helvetica Neue"/>
+              </a:rPr>
+              <a:t>安部  新司</a:t>
+            </a:r>
+          </a:p>
+        </p:txBody>
+      </p:sp>
+      <p:sp>
+        <p:nvSpPr>
+          <p:cNvPr id="140" name="statement"/>
           <p:cNvSpPr txBox="1"/>
           <p:nvPr/>
         </p:nvSpPr>
         <p:spPr>
           <a:xfrm>
-            <a:off x="288000" y="1134000"/>
-            <a:ext cx="2160000" cy="180000"/>
+            <a:off x="216000" y="1692000"/>
+            <a:ext cx="3060000" cy="144000"/>
           </a:xfrm>
           <a:prstGeom prst="rect">
             <a:avLst/>
@@ -1003,29 +1069,73 @@
           <a:p>
             <a:pPr algn="l"/>
             <a:r>
-              <a:rPr lang="ja-JP" sz="1200" kern="0">
+              <a:rPr lang="ja-JP" sz="650" b="1" spc="91" kern="0">
                 <a:solidFill>
                   <a:srgbClr val="5A5852"/>
                 </a:solidFill>
-                <a:latin typeface="EB Garamond"/>
-                <a:ea typeface="Hiragino Mincho ProN"/>
-                <a:cs typeface="EB Garamond"/>
-              </a:rPr>
-              <a:t>安部 新司</a:t>
-            </a:r>
-          </a:p>
-        </p:txBody>
-      </p:sp>
-      <p:sp>
-        <p:nvSpPr>
-          <p:cNvPr id="122" name="title"/>
+                <a:latin typeface="Helvetica Neue"/>
+                <a:ea typeface="Hiragino Sans"/>
+                <a:cs typeface="Helvetica Neue"/>
+              </a:rPr>
+              <a:t>OSINT</a:t>
+            </a:r>
+            <a:r>
+              <a:rPr lang="ja-JP" sz="650" kern="0">
+                <a:solidFill>
+                  <a:srgbClr val="A3A098"/>
+                </a:solidFill>
+                <a:latin typeface="Helvetica Neue"/>
+                <a:ea typeface="Hiragino Sans"/>
+                <a:cs typeface="Helvetica Neue"/>
+              </a:rPr>
+              <a:t>  ·  </a:t>
+            </a:r>
+            <a:r>
+              <a:rPr lang="ja-JP" sz="650" b="1" spc="91" kern="0">
+                <a:solidFill>
+                  <a:srgbClr val="5A5852"/>
+                </a:solidFill>
+                <a:latin typeface="Helvetica Neue"/>
+                <a:ea typeface="Hiragino Sans"/>
+                <a:cs typeface="Helvetica Neue"/>
+              </a:rPr>
+              <a:t>MACHINE LEARNING</a:t>
+            </a:r>
+            <a:r>
+              <a:rPr lang="ja-JP" sz="650" kern="0">
+                <a:solidFill>
+                  <a:srgbClr val="A3A098"/>
+                </a:solidFill>
+                <a:latin typeface="Helvetica Neue"/>
+                <a:ea typeface="Hiragino Sans"/>
+                <a:cs typeface="Helvetica Neue"/>
+              </a:rPr>
+              <a:t>  ·  </a:t>
+            </a:r>
+            <a:r>
+              <a:rPr lang="ja-JP" sz="650" b="1" spc="91" kern="0">
+                <a:solidFill>
+                  <a:srgbClr val="5A5852"/>
+                </a:solidFill>
+                <a:latin typeface="Helvetica Neue"/>
+                <a:ea typeface="Hiragino Sans"/>
+                <a:cs typeface="Helvetica Neue"/>
+              </a:rPr>
+              <a:t>INFORMATION THEORY</a:t>
+            </a:r>
+          </a:p>
+        </p:txBody>
+      </p:sp>
+      <p:sp>
+        <p:nvSpPr>
+          <p:cNvPr id="150" name="email"/>
           <p:cNvSpPr txBox="1"/>
           <p:nvPr/>
         </p:nvSpPr>
         <p:spPr>
           <a:xfrm>
-            <a:off x="1980000" y="1141200"/>
-            <a:ext cx="1224000" cy="180000"/>
+            <a:off x="216000" y="1929600"/>
+            <a:ext cx="2160000" cy="115200"/>
           </a:xfrm>
           <a:prstGeom prst="rect">
             <a:avLst/>
@@ -1038,275 +1148,17 @@
           </a:bodyPr>
           <a:lstStyle/>
           <a:p>
-            <a:pPr algn="r"/>
-            <a:r>
-              <a:rPr lang="ja-JP" sz="1050" i="1" kern="0">
+            <a:pPr algn="l"/>
+            <a:r>
+              <a:rPr lang="ja-JP" sz="700" spc="28" kern="0">
                 <a:solidFill>
                   <a:srgbClr val="0E0E0C"/>
                 </a:solidFill>
-                <a:latin typeface="EB Garamond"/>
-                <a:ea typeface="Hiragino Sans"/>
-                <a:cs typeface="EB Garamond"/>
-              </a:rPr>
-              <a:t>Independent</a:t>
-            </a:r>
-          </a:p>
-        </p:txBody>
-      </p:sp>
-      <p:sp>
-        <p:nvSpPr>
-          <p:cNvPr id="130" name="rule-mid"/>
-          <p:cNvSpPr/>
-          <p:nvPr/>
-        </p:nvSpPr>
-        <p:spPr>
-          <a:xfrm>
-            <a:off x="288000" y="1504800"/>
-            <a:ext cx="2916000" cy="3600"/>
-          </a:xfrm>
-          <a:prstGeom prst="rect">
-            <a:avLst/>
-          </a:prstGeom>
-          <a:solidFill>
-            <a:srgbClr val="5A5852"/>
-          </a:solidFill>
-          <a:ln>
-            <a:noFill/>
-          </a:ln>
-        </p:spPr>
-        <p:txBody>
-          <a:bodyPr/>
-          <a:lstStyle/>
-          <a:p>
-            <a:endParaRPr lang="ja-JP"/>
-          </a:p>
-        </p:txBody>
-      </p:sp>
-      <p:sp>
-        <p:nvSpPr>
-          <p:cNvPr id="131" name="lattice-label"/>
-          <p:cNvSpPr txBox="1"/>
-          <p:nvPr/>
-        </p:nvSpPr>
-        <p:spPr>
-          <a:xfrm>
-            <a:off x="288000" y="1569600"/>
-            <a:ext cx="1080000" cy="126000"/>
-          </a:xfrm>
-          <a:prstGeom prst="rect">
-            <a:avLst/>
-          </a:prstGeom>
-          <a:noFill/>
-        </p:spPr>
-        <p:txBody>
-          <a:bodyPr wrap="square" lIns="0" tIns="0" rIns="0" bIns="0" rtlCol="0" anchor="t">
-            <a:noAutofit/>
-          </a:bodyPr>
-          <a:lstStyle/>
-          <a:p>
-            <a:pPr algn="l"/>
-            <a:r>
-              <a:rPr lang="ja-JP" sz="600" spc="132" kern="0">
-                <a:solidFill>
-                  <a:srgbClr val="A3A098"/>
-                </a:solidFill>
-                <a:latin typeface="JetBrains Mono"/>
-                <a:ea typeface="Hiragino Sans"/>
-                <a:cs typeface="JetBrains Mono"/>
-              </a:rPr>
-              <a:t>DISCIPLINES</a:t>
-            </a:r>
-          </a:p>
-        </p:txBody>
-      </p:sp>
-      <p:sp>
-        <p:nvSpPr>
-          <p:cNvPr id="132" name="lattice"/>
-          <p:cNvSpPr txBox="1"/>
-          <p:nvPr/>
-        </p:nvSpPr>
-        <p:spPr>
-          <a:xfrm>
-            <a:off x="288000" y="1699200"/>
-            <a:ext cx="2916000" cy="144000"/>
-          </a:xfrm>
-          <a:prstGeom prst="rect">
-            <a:avLst/>
-          </a:prstGeom>
-          <a:noFill/>
-        </p:spPr>
-        <p:txBody>
-          <a:bodyPr wrap="square" lIns="0" tIns="0" rIns="0" bIns="0" rtlCol="0" anchor="t">
-            <a:noAutofit/>
-          </a:bodyPr>
-          <a:lstStyle/>
-          <a:p>
-            <a:pPr algn="l"/>
-            <a:r>
-              <a:rPr lang="ja-JP" sz="900" b="1" spc="144" kern="0">
-                <a:solidFill>
-                  <a:srgbClr val="0E0E0C"/>
-                </a:solidFill>
-                <a:latin typeface="JetBrains Mono"/>
-                <a:ea typeface="Hiragino Sans"/>
-                <a:cs typeface="JetBrains Mono"/>
-              </a:rPr>
-              <a:t>OSINT</a:t>
-            </a:r>
-            <a:r>
-              <a:rPr lang="ja-JP" sz="900" kern="0">
-                <a:solidFill>
-                  <a:srgbClr val="A3A098"/>
-                </a:solidFill>
-                <a:latin typeface="JetBrains Mono"/>
-                <a:ea typeface="Hiragino Sans"/>
-                <a:cs typeface="JetBrains Mono"/>
-              </a:rPr>
-              <a:t>    ·    </a:t>
-            </a:r>
-            <a:r>
-              <a:rPr lang="ja-JP" sz="900" b="1" spc="144" kern="0">
-                <a:solidFill>
-                  <a:srgbClr val="0E0E0C"/>
-                </a:solidFill>
-                <a:latin typeface="JetBrains Mono"/>
-                <a:ea typeface="Hiragino Sans"/>
-                <a:cs typeface="JetBrains Mono"/>
-              </a:rPr>
-              <a:t>ML</a:t>
-            </a:r>
-            <a:r>
-              <a:rPr lang="ja-JP" sz="900" kern="0">
-                <a:solidFill>
-                  <a:srgbClr val="A3A098"/>
-                </a:solidFill>
-                <a:latin typeface="JetBrains Mono"/>
-                <a:ea typeface="Hiragino Sans"/>
-                <a:cs typeface="JetBrains Mono"/>
-              </a:rPr>
-              <a:t>    ·    </a:t>
-            </a:r>
-            <a:r>
-              <a:rPr lang="ja-JP" sz="900" b="1" spc="144" kern="0">
-                <a:solidFill>
-                  <a:srgbClr val="0E0E0C"/>
-                </a:solidFill>
-                <a:latin typeface="JetBrains Mono"/>
-                <a:ea typeface="Hiragino Sans"/>
-                <a:cs typeface="JetBrains Mono"/>
-              </a:rPr>
-              <a:t>INFO-TH</a:t>
-            </a:r>
-          </a:p>
-        </p:txBody>
-      </p:sp>
-      <p:sp>
-        <p:nvSpPr>
-          <p:cNvPr id="150" name="email"/>
-          <p:cNvSpPr txBox="1"/>
-          <p:nvPr/>
-        </p:nvSpPr>
-        <p:spPr>
-          <a:xfrm>
-            <a:off x="288000" y="1965600"/>
-            <a:ext cx="1620000" cy="115200"/>
-          </a:xfrm>
-          <a:prstGeom prst="rect">
-            <a:avLst/>
-          </a:prstGeom>
-          <a:noFill/>
-        </p:spPr>
-        <p:txBody>
-          <a:bodyPr wrap="square" lIns="0" tIns="0" rIns="0" bIns="0" rtlCol="0" anchor="t">
-            <a:noAutofit/>
-          </a:bodyPr>
-          <a:lstStyle/>
-          <a:p>
-            <a:pPr algn="l"/>
-            <a:r>
-              <a:rPr lang="ja-JP" sz="700" spc="28" kern="0">
-                <a:solidFill>
-                  <a:srgbClr val="0E0E0C"/>
-                </a:solidFill>
-                <a:latin typeface="JetBrains Mono"/>
-                <a:ea typeface="Hiragino Sans"/>
-                <a:cs typeface="JetBrains Mono"/>
+                <a:latin typeface="Helvetica Neue"/>
+                <a:ea typeface="Hiragino Sans"/>
+                <a:cs typeface="Helvetica Neue"/>
               </a:rPr>
               <a:t>4beshinji@gmail.com</a:t>
-            </a:r>
-          </a:p>
-        </p:txBody>
-      </p:sp>
-      <p:sp>
-        <p:nvSpPr>
-          <p:cNvPr id="151" name="url"/>
-          <p:cNvSpPr txBox="1"/>
-          <p:nvPr/>
-        </p:nvSpPr>
-        <p:spPr>
-          <a:xfrm>
-            <a:off x="1980000" y="1965600"/>
-            <a:ext cx="1080000" cy="115200"/>
-          </a:xfrm>
-          <a:prstGeom prst="rect">
-            <a:avLst/>
-          </a:prstGeom>
-          <a:noFill/>
-        </p:spPr>
-        <p:txBody>
-          <a:bodyPr wrap="square" lIns="0" tIns="0" rIns="0" bIns="0" rtlCol="0" anchor="t">
-            <a:noAutofit/>
-          </a:bodyPr>
-          <a:lstStyle/>
-          <a:p>
-            <a:pPr algn="r"/>
-            <a:r>
-              <a:rPr lang="ja-JP" sz="700" b="1" spc="28" kern="0">
-                <a:solidFill>
-                  <a:srgbClr val="0E0E0C"/>
-                </a:solidFill>
-                <a:latin typeface="JetBrains Mono"/>
-                <a:ea typeface="Hiragino Sans"/>
-                <a:cs typeface="JetBrains Mono"/>
-              </a:rPr>
-              <a:t>tangle-tech.com</a:t>
-            </a:r>
-          </a:p>
-        </p:txBody>
-      </p:sp>
-      <p:sp>
-        <p:nvSpPr>
-          <p:cNvPr id="152" name="accent-mark"/>
-          <p:cNvSpPr txBox="1"/>
-          <p:nvPr/>
-        </p:nvSpPr>
-        <p:spPr>
-          <a:xfrm>
-            <a:off x="3096000" y="1958400"/>
-            <a:ext cx="144000" cy="126000"/>
-          </a:xfrm>
-          <a:prstGeom prst="rect">
-            <a:avLst/>
-          </a:prstGeom>
-          <a:noFill/>
-        </p:spPr>
-        <p:txBody>
-          <a:bodyPr wrap="square" lIns="0" tIns="0" rIns="0" bIns="0" rtlCol="0" anchor="t">
-            <a:noAutofit/>
-          </a:bodyPr>
-          <a:lstStyle/>
-          <a:p>
-            <a:pPr algn="r"/>
-            <a:r>
-              <a:rPr lang="ja-JP" sz="800" b="1" kern="0">
-                <a:solidFill>
-                  <a:srgbClr val="FF3B1C"/>
-                </a:solidFill>
-                <a:latin typeface="JetBrains Mono"/>
-                <a:ea typeface="Hiragino Sans"/>
-                <a:cs typeface="JetBrains Mono"/>
-              </a:rPr>
-              <a:t>§</a:t>
             </a:r>
           </a:p>
         </p:txBody>
@@ -1367,14 +1219,62 @@
       </p:sp>
       <p:sp>
         <p:nvSpPr>
+          <p:cNvPr id="110" name="top-label"/>
+          <p:cNvSpPr txBox="1"/>
+          <p:nvPr/>
+        </p:nvSpPr>
+        <p:spPr>
+          <a:xfrm>
+            <a:off x="216000" y="244800"/>
+            <a:ext cx="1080000" cy="126000"/>
+          </a:xfrm>
+          <a:prstGeom prst="rect">
+            <a:avLst/>
+          </a:prstGeom>
+          <a:noFill/>
+        </p:spPr>
+        <p:txBody>
+          <a:bodyPr wrap="square" lIns="0" tIns="0" rIns="0" bIns="0" rtlCol="0" anchor="t">
+            <a:noAutofit/>
+          </a:bodyPr>
+          <a:lstStyle/>
+          <a:p>
+            <a:pPr algn="l"/>
+            <a:r>
+              <a:rPr lang="ja-JP" sz="600" b="1" kern="0">
+                <a:solidFill>
+                  <a:srgbClr val="FF3B1C"/>
+                </a:solidFill>
+                <a:latin typeface="Helvetica Neue"/>
+                <a:ea typeface="Hiragino Sans"/>
+                <a:cs typeface="Helvetica Neue"/>
+              </a:rPr>
+              <a:t>§</a:t>
+            </a:r>
+            <a:r>
+              <a:rPr lang="ja-JP" sz="600" b="1" spc="168" kern="0">
+                <a:solidFill>
+                  <a:srgbClr val="A3A098"/>
+                </a:solidFill>
+                <a:latin typeface="Helvetica Neue"/>
+                <a:ea typeface="Hiragino Sans"/>
+                <a:cs typeface="Helvetica Neue"/>
+              </a:rPr>
+              <a:t>  MISSION</a:t>
+            </a:r>
+          </a:p>
+        </p:txBody>
+      </p:sp>
+      <p:sp>
+        <p:nvSpPr>
           <p:cNvPr id="101" name="rule-top"/>
           <p:cNvSpPr/>
           <p:nvPr/>
         </p:nvSpPr>
         <p:spPr>
           <a:xfrm>
-            <a:off x="288000" y="410400"/>
-            <a:ext cx="2916000" cy="3600"/>
+            <a:off x="216000" y="410400"/>
+            <a:ext cx="3060000" cy="3600"/>
           </a:xfrm>
           <a:prstGeom prst="rect">
             <a:avLst/>
@@ -1396,14 +1296,43 @@
       </p:sp>
       <p:sp>
         <p:nvSpPr>
-          <p:cNvPr id="110" name="back-tag"/>
+          <p:cNvPr id="190" name="rule-bottom"/>
+          <p:cNvSpPr/>
+          <p:nvPr/>
+        </p:nvSpPr>
+        <p:spPr>
+          <a:xfrm>
+            <a:off x="216000" y="1857600"/>
+            <a:ext cx="3060000" cy="3600"/>
+          </a:xfrm>
+          <a:prstGeom prst="rect">
+            <a:avLst/>
+          </a:prstGeom>
+          <a:solidFill>
+            <a:srgbClr val="5A5852"/>
+          </a:solidFill>
+          <a:ln>
+            <a:noFill/>
+          </a:ln>
+        </p:spPr>
+        <p:txBody>
+          <a:bodyPr/>
+          <a:lstStyle/>
+          <a:p>
+            <a:endParaRPr lang="ja-JP"/>
+          </a:p>
+        </p:txBody>
+      </p:sp>
+      <p:sp>
+        <p:nvSpPr>
+          <p:cNvPr id="192" name="bottom-accent"/>
           <p:cNvSpPr txBox="1"/>
           <p:nvPr/>
         </p:nvSpPr>
         <p:spPr>
           <a:xfrm>
-            <a:off x="288000" y="244800"/>
-            <a:ext cx="1080000" cy="126000"/>
+            <a:off x="3096000" y="1911600"/>
+            <a:ext cx="180000" cy="144000"/>
           </a:xfrm>
           <a:prstGeom prst="rect">
             <a:avLst/>
@@ -1416,42 +1345,31 @@
           </a:bodyPr>
           <a:lstStyle/>
           <a:p>
-            <a:pPr algn="l"/>
-            <a:r>
-              <a:rPr lang="ja-JP" sz="650" b="1" spc="117" kern="0">
+            <a:pPr algn="r"/>
+            <a:r>
+              <a:rPr lang="ja-JP" sz="900" b="1" kern="0">
                 <a:solidFill>
                   <a:srgbClr val="FF3B1C"/>
                 </a:solidFill>
-                <a:latin typeface="JetBrains Mono"/>
-                <a:ea typeface="Hiragino Sans"/>
-                <a:cs typeface="JetBrains Mono"/>
+                <a:latin typeface="Helvetica Neue"/>
+                <a:ea typeface="Hiragino Sans"/>
+                <a:cs typeface="Helvetica Neue"/>
               </a:rPr>
               <a:t>§</a:t>
             </a:r>
-            <a:r>
-              <a:rPr lang="ja-JP" sz="650" spc="143" kern="0">
-                <a:solidFill>
-                  <a:srgbClr val="5A5852"/>
-                </a:solidFill>
-                <a:latin typeface="JetBrains Mono"/>
-                <a:ea typeface="Hiragino Sans"/>
-                <a:cs typeface="JetBrains Mono"/>
-              </a:rPr>
-              <a:t> MISSION</a:t>
-            </a:r>
-          </a:p>
-        </p:txBody>
-      </p:sp>
-      <p:sp>
-        <p:nvSpPr>
-          <p:cNvPr id="111" name="back-wordmark"/>
+          </a:p>
+        </p:txBody>
+      </p:sp>
+      <p:sp>
+        <p:nvSpPr>
+          <p:cNvPr id="120" name="tagline-l1"/>
           <p:cNvSpPr txBox="1"/>
           <p:nvPr/>
         </p:nvSpPr>
         <p:spPr>
           <a:xfrm>
-            <a:off x="1980000" y="244800"/>
-            <a:ext cx="1224000" cy="126000"/>
+            <a:off x="216000" y="540000"/>
+            <a:ext cx="3060000" cy="252000"/>
           </a:xfrm>
           <a:prstGeom prst="rect">
             <a:avLst/>
@@ -1464,31 +1382,31 @@
           </a:bodyPr>
           <a:lstStyle/>
           <a:p>
-            <a:pPr algn="r"/>
-            <a:r>
-              <a:rPr lang="ja-JP" sz="650" b="1" spc="143" kern="0">
+            <a:pPr algn="l"/>
+            <a:r>
+              <a:rPr lang="ja-JP" sz="1700" b="1" spc="17" kern="0">
                 <a:solidFill>
                   <a:srgbClr val="0E0E0C"/>
                 </a:solidFill>
-                <a:latin typeface="JetBrains Mono"/>
-                <a:ea typeface="Hiragino Sans"/>
-                <a:cs typeface="JetBrains Mono"/>
-              </a:rPr>
-              <a:t>TANGLETECK</a:t>
-            </a:r>
-          </a:p>
-        </p:txBody>
-      </p:sp>
-      <p:sp>
-        <p:nvSpPr>
-          <p:cNvPr id="120" name="tagline-jp"/>
+                <a:latin typeface="Helvetica Neue"/>
+                <a:ea typeface="Hiragino Sans"/>
+                <a:cs typeface="Helvetica Neue"/>
+              </a:rPr>
+              <a:t>もつれた課題を、</a:t>
+            </a:r>
+          </a:p>
+        </p:txBody>
+      </p:sp>
+      <p:sp>
+        <p:nvSpPr>
+          <p:cNvPr id="121" name="tagline-l2"/>
           <p:cNvSpPr txBox="1"/>
           <p:nvPr/>
         </p:nvSpPr>
         <p:spPr>
           <a:xfrm>
-            <a:off x="216000" y="792000"/>
-            <a:ext cx="3060000" cy="324000"/>
+            <a:off x="216000" y="846000"/>
+            <a:ext cx="3060000" cy="252000"/>
           </a:xfrm>
           <a:prstGeom prst="rect">
             <a:avLst/>
@@ -1501,31 +1419,31 @@
           </a:bodyPr>
           <a:lstStyle/>
           <a:p>
-            <a:pPr algn="ctr"/>
-            <a:r>
-              <a:rPr lang="ja-JP" sz="1700" spc="102" kern="0">
-                <a:solidFill>
-                  <a:srgbClr val="0E0E0C"/>
-                </a:solidFill>
-                <a:latin typeface="EB Garamond"/>
-                <a:ea typeface="Hiragino Mincho ProN"/>
-                <a:cs typeface="EB Garamond"/>
-              </a:rPr>
-              <a:t>もつれた課題を、解きほぐす。</a:t>
-            </a:r>
-          </a:p>
-        </p:txBody>
-      </p:sp>
-      <p:sp>
-        <p:nvSpPr>
-          <p:cNvPr id="121" name="tagline-en"/>
+            <a:pPr algn="l"/>
+            <a:r>
+              <a:rPr lang="ja-JP" sz="1700" b="1" spc="17" kern="0">
+                <a:solidFill>
+                  <a:srgbClr val="FF3B1C"/>
+                </a:solidFill>
+                <a:latin typeface="Helvetica Neue"/>
+                <a:ea typeface="Hiragino Sans"/>
+                <a:cs typeface="Helvetica Neue"/>
+              </a:rPr>
+              <a:t>解きほぐす。</a:t>
+            </a:r>
+          </a:p>
+        </p:txBody>
+      </p:sp>
+      <p:sp>
+        <p:nvSpPr>
+          <p:cNvPr id="122" name="paraphrase"/>
           <p:cNvSpPr txBox="1"/>
           <p:nvPr/>
         </p:nvSpPr>
         <p:spPr>
           <a:xfrm>
-            <a:off x="216000" y="1242000"/>
-            <a:ext cx="3060000" cy="180000"/>
+            <a:off x="216000" y="1188000"/>
+            <a:ext cx="3060000" cy="162000"/>
           </a:xfrm>
           <a:prstGeom prst="rect">
             <a:avLst/>
@@ -1538,60 +1456,42 @@
           </a:bodyPr>
           <a:lstStyle/>
           <a:p>
-            <a:pPr algn="ctr"/>
-            <a:r>
-              <a:rPr lang="ja-JP" sz="1000" i="1" kern="0">
+            <a:pPr algn="l"/>
+            <a:r>
+              <a:rPr lang="ja-JP" sz="850" i="1" spc="85" kern="0">
                 <a:solidFill>
                   <a:srgbClr val="5A5852"/>
                 </a:solidFill>
-                <a:latin typeface="EB Garamond"/>
-                <a:ea typeface="Hiragino Sans"/>
-                <a:cs typeface="EB Garamond"/>
-              </a:rPr>
-              <a:t>Untangle what is tangled.</a:t>
-            </a:r>
-          </a:p>
-        </p:txBody>
-      </p:sp>
-      <p:sp>
-        <p:nvSpPr>
-          <p:cNvPr id="122" name="rule-bottom"/>
-          <p:cNvSpPr/>
-          <p:nvPr/>
-        </p:nvSpPr>
-        <p:spPr>
-          <a:xfrm>
-            <a:off x="288000" y="1746000"/>
-            <a:ext cx="2916000" cy="3600"/>
-          </a:xfrm>
-          <a:prstGeom prst="rect">
-            <a:avLst/>
-          </a:prstGeom>
-          <a:solidFill>
-            <a:srgbClr val="5A5852"/>
-          </a:solidFill>
-          <a:ln>
-            <a:noFill/>
-          </a:ln>
-        </p:spPr>
-        <p:txBody>
-          <a:bodyPr/>
-          <a:lstStyle/>
-          <a:p>
-            <a:endParaRPr lang="ja-JP"/>
-          </a:p>
-        </p:txBody>
-      </p:sp>
-      <p:sp>
-        <p:nvSpPr>
-          <p:cNvPr id="130" name="lattice-back"/>
+                <a:latin typeface="Helvetica Neue"/>
+                <a:ea typeface="Hiragino Sans"/>
+                <a:cs typeface="Helvetica Neue"/>
+              </a:rPr>
+              <a:t>//  </a:t>
+            </a:r>
+            <a:r>
+              <a:rPr lang="ja-JP" sz="850" i="1" spc="85" kern="0">
+                <a:solidFill>
+                  <a:srgbClr val="5A5852"/>
+                </a:solidFill>
+                <a:latin typeface="Helvetica Neue"/>
+                <a:ea typeface="Hiragino Sans"/>
+                <a:cs typeface="Helvetica Neue"/>
+              </a:rPr>
+              <a:t>untangle what is tangled</a:t>
+            </a:r>
+          </a:p>
+        </p:txBody>
+      </p:sp>
+      <p:sp>
+        <p:nvSpPr>
+          <p:cNvPr id="140" name="wordmark"/>
           <p:cNvSpPr txBox="1"/>
           <p:nvPr/>
         </p:nvSpPr>
         <p:spPr>
           <a:xfrm>
-            <a:off x="216000" y="1821600"/>
-            <a:ext cx="3060000" cy="126000"/>
+            <a:off x="216000" y="1504800"/>
+            <a:ext cx="3060000" cy="324000"/>
           </a:xfrm>
           <a:prstGeom prst="rect">
             <a:avLst/>
@@ -1604,31 +1504,42 @@
           </a:bodyPr>
           <a:lstStyle/>
           <a:p>
-            <a:pPr algn="ctr"/>
-            <a:r>
-              <a:rPr lang="ja-JP" sz="600" spc="108" kern="0">
-                <a:solidFill>
-                  <a:srgbClr val="A3A098"/>
-                </a:solidFill>
-                <a:latin typeface="JetBrains Mono"/>
-                <a:ea typeface="Hiragino Sans"/>
-                <a:cs typeface="JetBrains Mono"/>
-              </a:rPr>
-              <a:t>AGR · BIO · IOT · CV · ML · LLM · ECON · EMB</a:t>
-            </a:r>
-          </a:p>
-        </p:txBody>
-      </p:sp>
-      <p:sp>
-        <p:nvSpPr>
-          <p:cNvPr id="131" name="url-back"/>
+            <a:pPr algn="l"/>
+            <a:r>
+              <a:rPr lang="ja-JP" sz="2200" b="1" spc="-55" kern="0">
+                <a:solidFill>
+                  <a:srgbClr val="0E0E0C"/>
+                </a:solidFill>
+                <a:latin typeface="Helvetica Neue"/>
+                <a:ea typeface="Hiragino Sans"/>
+                <a:cs typeface="Helvetica Neue"/>
+              </a:rPr>
+              <a:t>TangleTeck</a:t>
+            </a:r>
+            <a:r>
+              <a:rPr lang="ja-JP" sz="2200" b="1" kern="0">
+                <a:solidFill>
+                  <a:srgbClr val="FF3B1C"/>
+                </a:solidFill>
+                <a:latin typeface="Helvetica Neue"/>
+                <a:ea typeface="Hiragino Sans"/>
+                <a:cs typeface="Helvetica Neue"/>
+              </a:rPr>
+              <a:t>.</a:t>
+            </a:r>
+          </a:p>
+        </p:txBody>
+      </p:sp>
+      <p:sp>
+        <p:nvSpPr>
+          <p:cNvPr id="150" name="url"/>
           <p:cNvSpPr txBox="1"/>
           <p:nvPr/>
         </p:nvSpPr>
         <p:spPr>
           <a:xfrm>
-            <a:off x="216000" y="1987200"/>
-            <a:ext cx="3060000" cy="126000"/>
+            <a:off x="216000" y="1929600"/>
+            <a:ext cx="2160000" cy="115200"/>
           </a:xfrm>
           <a:prstGeom prst="rect">
             <a:avLst/>
@@ -1641,15 +1552,15 @@
           </a:bodyPr>
           <a:lstStyle/>
           <a:p>
-            <a:pPr algn="ctr"/>
-            <a:r>
-              <a:rPr lang="ja-JP" sz="700" b="1" spc="56" kern="0">
+            <a:pPr algn="l"/>
+            <a:r>
+              <a:rPr lang="ja-JP" sz="700" spc="28" kern="0">
                 <a:solidFill>
                   <a:srgbClr val="0E0E0C"/>
                 </a:solidFill>
-                <a:latin typeface="JetBrains Mono"/>
-                <a:ea typeface="Hiragino Sans"/>
-                <a:cs typeface="JetBrains Mono"/>
+                <a:latin typeface="Helvetica Neue"/>
+                <a:ea typeface="Hiragino Sans"/>
+                <a:cs typeface="Helvetica Neue"/>
               </a:rPr>
               <a:t>tangle-tech.com</a:t>
             </a:r>

</xml_diff>